<commit_message>
sd-11-007: qualify upserts and message de-duplication
Co-Authored-By: Claude Sonnet 5.5 <noreply@anthropic.com>
Claude-Session: https://claude.ai/code/session_0121Z35eF2EmPsW9asDgHWsZ
</commit_message>
<xml_diff>
--- a/system-design-101/vi/lessons/sd-11-007/slides/sd-11-007.pptx
+++ b/system-design-101/vi/lessons/sd-11-007/slides/sd-11-007.pptx
@@ -7802,10 +7802,10 @@
                 <a:ea typeface="Be Vietnam Pro" pitchFamily="34" charset="-122"/>
                 <a:cs typeface="Be Vietnam Pro" pitchFamily="34" charset="-120"/>
               </a:rPr>
-              <a:t> lý,</a:t>
-            </a:r>
-            <a:r>
-              <a:rPr lang="en-US" sz="2250" b="1" dirty="0" spc="2" kern="0">
+              <a:t> lý</a:t>
+            </a:r>
+            <a:r>
+              <a:rPr lang="en-US" sz="2250" b="1" dirty="0" spc="4" kern="0">
                 <a:solidFill>
                   <a:srgbClr val="0F766E"/>
                 </a:solidFill>
@@ -7813,10 +7813,21 @@
                 <a:ea typeface="Be Vietnam Pro" pitchFamily="34" charset="-122"/>
                 <a:cs typeface="Be Vietnam Pro" pitchFamily="34" charset="-120"/>
               </a:rPr>
+              <a:t> +</a:t>
+            </a:r>
+            <a:r>
+              <a:rPr lang="en-US" sz="2250" b="1" dirty="0" spc="3" kern="0">
+                <a:solidFill>
+                  <a:srgbClr val="0F766E"/>
+                </a:solidFill>
+                <a:latin typeface="Be Vietnam Pro" pitchFamily="34" charset="0"/>
+                <a:ea typeface="Be Vietnam Pro" pitchFamily="34" charset="-122"/>
+                <a:cs typeface="Be Vietnam Pro" pitchFamily="34" charset="-120"/>
+              </a:rPr>
               <a:t> ghi</a:t>
             </a:r>
             <a:r>
-              <a:rPr lang="en-US" sz="2250" b="1" dirty="0" spc="0" kern="0">
+              <a:rPr lang="en-US" sz="2250" b="1" dirty="0" spc="-1" kern="0">
                 <a:solidFill>
                   <a:srgbClr val="0F766E"/>
                 </a:solidFill>
@@ -7835,7 +7846,51 @@
                 <a:ea typeface="Be Vietnam Pro" pitchFamily="34" charset="-122"/>
                 <a:cs typeface="Be Vietnam Pro" pitchFamily="34" charset="-120"/>
               </a:rPr>
-              <a:t> A</a:t>
+              <a:t> A,</a:t>
+            </a:r>
+            <a:r>
+              <a:rPr lang="en-US" sz="2250" b="1" dirty="0" spc="-3" kern="0">
+                <a:solidFill>
+                  <a:srgbClr val="0F766E"/>
+                </a:solidFill>
+                <a:latin typeface="Be Vietnam Pro" pitchFamily="34" charset="0"/>
+                <a:ea typeface="Be Vietnam Pro" pitchFamily="34" charset="-122"/>
+                <a:cs typeface="Be Vietnam Pro" pitchFamily="34" charset="-120"/>
+              </a:rPr>
+              <a:t> cùng</a:t>
+            </a:r>
+            <a:r>
+              <a:rPr lang="en-US" sz="2250" b="1" dirty="0" spc="-6" kern="0">
+                <a:solidFill>
+                  <a:srgbClr val="0F766E"/>
+                </a:solidFill>
+                <a:latin typeface="Be Vietnam Pro" pitchFamily="34" charset="0"/>
+                <a:ea typeface="Be Vietnam Pro" pitchFamily="34" charset="-122"/>
+                <a:cs typeface="Be Vietnam Pro" pitchFamily="34" charset="-120"/>
+              </a:rPr>
+              <a:t> một</a:t>
+            </a:r>
+            <a:r>
+              <a:rPr lang="en-US" sz="2250" b="1" dirty="0" spc="6" kern="0">
+                <a:solidFill>
+                  <a:srgbClr val="0F766E"/>
+                </a:solidFill>
+                <a:latin typeface="Be Vietnam Pro" pitchFamily="34" charset="0"/>
+                <a:ea typeface="Be Vietnam Pro" pitchFamily="34" charset="-122"/>
+                <a:cs typeface="Be Vietnam Pro" pitchFamily="34" charset="-120"/>
+              </a:rPr>
+              <a:t> giao</a:t>
+            </a:r>
+            <a:r>
+              <a:rPr lang="en-US" sz="2250" b="1" dirty="0" spc="4" kern="0">
+                <a:solidFill>
+                  <a:srgbClr val="0F766E"/>
+                </a:solidFill>
+                <a:latin typeface="Be Vietnam Pro" pitchFamily="34" charset="0"/>
+                <a:ea typeface="Be Vietnam Pro" pitchFamily="34" charset="-122"/>
+                <a:cs typeface="Be Vietnam Pro" pitchFamily="34" charset="-120"/>
+              </a:rPr>
+              <a:t> dịch</a:t>
             </a:r>
             <a:endParaRPr lang="en-US" sz="2250" dirty="0"/>
           </a:p>
@@ -8847,7 +8902,7 @@
       </p:sp>
       <p:sp>
         <p:nvSpPr>
-          <p:cNvPr id="7" name="Text richtext-1792421528786-745983140"/>
+          <p:cNvPr id="7" name="Text 5"/>
           <p:cNvSpPr/>
           <p:nvPr/>
         </p:nvSpPr>
@@ -8866,13 +8921,11 @@
           <a:bodyPr wrap="square" lIns="0" tIns="0" rIns="0" bIns="0" rtlCol="0" anchor="ctr"/>
           <a:lstStyle/>
           <a:p>
-            <a:pPr algn="l" marL="323850" indent="-231371">
+            <a:pPr algn="l" indent="0" marL="0">
               <a:spcAft>
                 <a:spcPts val="1050"/>
               </a:spcAft>
-              <a:buSzPct val="100000"/>
-              <a:buFont typeface="Arial"/>
-              <a:buChar char="•"/>
+              <a:buNone/>
             </a:pPr>
             <a:r>
               <a:rPr lang="en-US" sz="2550" dirty="0" spc="-5" kern="0">
@@ -8932,13 +8985,11 @@
             <a:endParaRPr lang="en-US" sz="2550" dirty="0"/>
           </a:p>
           <a:p>
-            <a:pPr algn="l" marL="323850" indent="-231371">
-              <a:buSzPct val="100000"/>
-              <a:buFont typeface="Arial"/>
-              <a:buChar char="•"/>
+            <a:pPr algn="l" indent="0" marL="0">
+              <a:buNone/>
             </a:pPr>
             <a:r>
-              <a:rPr lang="en-US" sz="2550" dirty="0" spc="8" kern="0">
+              <a:rPr lang="en-US" sz="2550" dirty="0" spc="-2" kern="0">
                 <a:solidFill>
                   <a:srgbClr val="E4E1D8"/>
                 </a:solidFill>
@@ -8946,10 +8997,10 @@
                 <a:ea typeface="Be Vietnam Pro" pitchFamily="34" charset="-122"/>
                 <a:cs typeface="Be Vietnam Pro" pitchFamily="34" charset="-120"/>
               </a:rPr>
-              <a:t>Chưa</a:t>
-            </a:r>
-            <a:r>
-              <a:rPr lang="en-US" sz="2550" dirty="0" spc="12" kern="0">
+              <a:t>Ghi</a:t>
+            </a:r>
+            <a:r>
+              <a:rPr lang="en-US" sz="2550" dirty="0" spc="1" kern="0">
                 <a:solidFill>
                   <a:srgbClr val="E4E1D8"/>
                 </a:solidFill>
@@ -8957,7 +9008,18 @@
                 <a:ea typeface="Be Vietnam Pro" pitchFamily="34" charset="-122"/>
                 <a:cs typeface="Be Vietnam Pro" pitchFamily="34" charset="-120"/>
               </a:rPr>
-              <a:t> đối</a:t>
+              <a:t> mã</a:t>
+            </a:r>
+            <a:r>
+              <a:rPr lang="en-US" sz="2550" dirty="0" spc="-18" kern="0">
+                <a:solidFill>
+                  <a:srgbClr val="E4E1D8"/>
+                </a:solidFill>
+                <a:latin typeface="Be Vietnam Pro" pitchFamily="34" charset="0"/>
+                <a:ea typeface="Be Vietnam Pro" pitchFamily="34" charset="-122"/>
+                <a:cs typeface="Be Vietnam Pro" pitchFamily="34" charset="-120"/>
+              </a:rPr>
+              <a:t> và</a:t>
             </a:r>
             <a:r>
               <a:rPr lang="en-US" sz="2550" dirty="0" spc="1" kern="0">
@@ -8968,10 +9030,10 @@
                 <a:ea typeface="Be Vietnam Pro" pitchFamily="34" charset="-122"/>
                 <a:cs typeface="Be Vietnam Pro" pitchFamily="34" charset="-120"/>
               </a:rPr>
-              <a:t> chiếu</a:t>
-            </a:r>
-            <a:r>
-              <a:rPr lang="en-US" sz="2550" dirty="0" spc="14" kern="0">
+              <a:t> hiệu</a:t>
+            </a:r>
+            <a:r>
+              <a:rPr lang="en-US" sz="2550" dirty="0" spc="24" kern="0">
                 <a:solidFill>
                   <a:srgbClr val="E4E1D8"/>
                 </a:solidFill>
@@ -8979,10 +9041,10 @@
                 <a:ea typeface="Be Vietnam Pro" pitchFamily="34" charset="-122"/>
                 <a:cs typeface="Be Vietnam Pro" pitchFamily="34" charset="-120"/>
               </a:rPr>
-              <a:t> đặc</a:t>
-            </a:r>
-            <a:r>
-              <a:rPr lang="en-US" sz="2550" dirty="0" spc="-16" kern="0">
+              <a:t> ứng</a:t>
+            </a:r>
+            <a:r>
+              <a:rPr lang="en-US" sz="2550" dirty="0" spc="0" kern="0">
                 <a:solidFill>
                   <a:srgbClr val="E4E1D8"/>
                 </a:solidFill>
@@ -8990,10 +9052,10 @@
                 <a:ea typeface="Be Vietnam Pro" pitchFamily="34" charset="-122"/>
                 <a:cs typeface="Be Vietnam Pro" pitchFamily="34" charset="-120"/>
               </a:rPr>
-              <a:t> tả</a:t>
-            </a:r>
-            <a:r>
-              <a:rPr lang="en-US" sz="2550" dirty="0" spc="-2" kern="0">
+              <a:t> phải</a:t>
+            </a:r>
+            <a:r>
+              <a:rPr lang="en-US" sz="2550" dirty="0" spc="-1" kern="0">
                 <a:solidFill>
                   <a:srgbClr val="E4E1D8"/>
                 </a:solidFill>
@@ -9001,7 +9063,18 @@
                 <a:ea typeface="Be Vietnam Pro" pitchFamily="34" charset="-122"/>
                 <a:cs typeface="Be Vietnam Pro" pitchFamily="34" charset="-120"/>
               </a:rPr>
-              <a:t> HTTP</a:t>
+              <a:t> cùng giao</a:t>
+            </a:r>
+            <a:r>
+              <a:rPr lang="en-US" sz="2550" dirty="0" spc="1" kern="0">
+                <a:solidFill>
+                  <a:srgbClr val="E4E1D8"/>
+                </a:solidFill>
+                <a:latin typeface="Be Vietnam Pro" pitchFamily="34" charset="0"/>
+                <a:ea typeface="Be Vietnam Pro" pitchFamily="34" charset="-122"/>
+                <a:cs typeface="Be Vietnam Pro" pitchFamily="34" charset="-120"/>
+              </a:rPr>
+              <a:t> dịch</a:t>
             </a:r>
             <a:endParaRPr lang="en-US" sz="2550" dirty="0"/>
           </a:p>

</xml_diff>